<commit_message>
docs(presentation): add PO Inbox demo act to pitch deck and script
</commit_message>
<xml_diff>
--- a/presentation/NexOrder-Pitch.pptx
+++ b/presentation/NexOrder-Pitch.pptx
@@ -10,6 +10,7 @@
     <p:sldId id="258" r:id="rId10"/>
     <p:sldId id="259" r:id="rId11"/>
     <p:sldId id="260" r:id="rId12"/>
+    <p:sldId id="261" r:id="rId13"/>
   </p:sldIdLst>
   <p:sldSz cx="12191695" cy="6858000" type="screen4x3"/>
   <p:notesSz cx="6858000" cy="9144000"/>
@@ -664,7 +665,7 @@
                 </a:solidFill>
                 <a:latin typeface="Calibri"/>
               </a:rPr>
-              <a:t>Walk this slide left to right. Spend 30 seconds per intake channel: self-serve is the customer's phone or laptop; telesales is the office rep keying it in with a call-reference number; field reps capture a customer signature on a tablet; the dashed box is the roadmap — email-in, WhatsApp, EDI — all designed to enter the same gate. The middle column is the architectural moat. Every intake channel hits the same Edge Function. That means pricing, promos, stock checks, and audit are guaranteed identical. The right column is what happens next — a deterministic pipeline that ops teams can rely on.</a:t>
+              <a:t>Walk this slide left to right. Spend 30 seconds per intake channel: self-serve is the customer's phone or laptop; telesales is the office rep keying it in with a call-reference number; field reps capture a customer signature on a tablet; the fourth box is now LIVE — emailed purchase orders are read by AI, reviewed, and turned into real orders (full detail on the next slide); WhatsApp and EDI are the remaining roadmap. The middle column is the architectural moat. Every intake channel hits the same Edge Function. That means pricing, promos, stock checks, and audit are guaranteed identical. The right column is what happens next — a deterministic pipeline that ops teams can rely on.</a:t>
             </a:r>
           </a:p>
         </p:txBody>
@@ -766,6 +767,82 @@
 </file>
 
 <file path=ppt/notesSlides/notesSlide5.xml><?xml version="1.0" encoding="utf-8"?>
+<p:notes xmlns:a="http://schemas.openxmlformats.org/drawingml/2006/main" xmlns:p="http://schemas.openxmlformats.org/presentationml/2006/main" xmlns:r="http://schemas.openxmlformats.org/officeDocument/2006/relationships">
+  <p:cSld>
+    <p:spTree>
+      <p:nvGrpSpPr>
+        <p:cNvPr id="1" name=""/>
+        <p:cNvGrpSpPr/>
+        <p:nvPr/>
+      </p:nvGrpSpPr>
+      <p:grpSpPr>
+        <a:xfrm>
+          <a:off x="0" y="0"/>
+          <a:ext cx="0" cy="0"/>
+          <a:chOff x="0" y="0"/>
+          <a:chExt cx="0" cy="0"/>
+        </a:xfrm>
+      </p:grpSpPr>
+      <p:sp>
+        <p:nvSpPr>
+          <p:cNvPr id="2" name="Slide Image Placeholder 1"/>
+          <p:cNvSpPr>
+            <a:spLocks noGrp="1"/>
+          </p:cNvSpPr>
+          <p:nvPr>
+            <p:ph type="sldImg" idx="2"/>
+          </p:nvPr>
+        </p:nvSpPr>
+        <p:spPr/>
+      </p:sp>
+      <p:sp>
+        <p:nvSpPr>
+          <p:cNvPr id="3" name="Notes Placeholder 2"/>
+          <p:cNvSpPr>
+            <a:spLocks noGrp="1"/>
+          </p:cNvSpPr>
+          <p:nvPr>
+            <p:ph type="body" idx="3" sz="quarter"/>
+          </p:nvPr>
+        </p:nvSpPr>
+        <p:spPr/>
+        <p:txBody>
+          <a:bodyPr/>
+          <a:lstStyle/>
+          <a:p>
+            <a:r>
+              <a:rPr sz="1100" b="0">
+                <a:solidFill>
+                  <a:srgbClr val="1F2937"/>
+                </a:solidFill>
+                <a:latin typeface="Calibri"/>
+              </a:rPr>
+              <a:t>This slide answers the objection you always get: 'our customers won't learn an app.' They don't have to. Most B2B buyers still send a purchase order by email or PDF — so we meet them there. Walk the four stages left to right: a connected mailbox is polled; the AI reads the PDF and body, ignores the email signature, and matches the sender to a customer and the free-text lines to your products — and it LEARNS, so the same buyer's next PO is a known quantity. Clean, confident, in-stock orders auto-approve with zero clicks; anything uncertain or short on stock is held with a confidence score and clear flags for a human. Approve, and it's a real order in the same list, realtime feed, and audit log as every other channel. One honest nuance for technical buyers: inbound POs land as orders for review — tier pricing and promotions are applied by ops at that point, not yet auto-resolved like the live cart. Bridge to the demo: 'Let me show you one land and get approved.'</a:t>
+            </a:r>
+          </a:p>
+        </p:txBody>
+      </p:sp>
+      <p:sp>
+        <p:nvSpPr>
+          <p:cNvPr id="4" name="Slide Number Placeholder 3"/>
+          <p:cNvSpPr>
+            <a:spLocks noGrp="1"/>
+          </p:cNvSpPr>
+          <p:nvPr>
+            <p:ph type="sldNum" idx="5" sz="quarter"/>
+          </p:nvPr>
+        </p:nvSpPr>
+        <p:spPr/>
+      </p:sp>
+    </p:spTree>
+  </p:cSld>
+  <p:clrMapOvr>
+    <a:masterClrMapping/>
+  </p:clrMapOvr>
+</p:notes>
+</file>
+
+<file path=ppt/notesSlides/notesSlide6.xml><?xml version="1.0" encoding="utf-8"?>
 <p:notes xmlns:a="http://schemas.openxmlformats.org/drawingml/2006/main" xmlns:p="http://schemas.openxmlformats.org/presentationml/2006/main" xmlns:r="http://schemas.openxmlformats.org/officeDocument/2006/relationships">
   <p:cSld>
     <p:spTree>
@@ -4048,7 +4125,7 @@
                 </a:solidFill>
                 <a:latin typeface="Calibri"/>
               </a:rPr>
-              <a:t>Nex Order   •   Pitch deck   •   Page 1 of 5</a:t>
+              <a:t>Nex Order   •   Pitch deck   •   Page 1 of 6</a:t>
             </a:r>
           </a:p>
         </p:txBody>
@@ -4670,7 +4747,7 @@
                 </a:solidFill>
                 <a:latin typeface="Calibri"/>
               </a:rPr>
-              <a:t>Nex Order   •   The problem   •   Page 2 of 5</a:t>
+              <a:t>Nex Order   •   The problem   •   Page 2 of 6</a:t>
             </a:r>
           </a:p>
         </p:txBody>
@@ -5289,13 +5366,12 @@
             </a:avLst>
           </a:prstGeom>
           <a:solidFill>
-            <a:srgbClr val="F8FAFC"/>
+            <a:srgbClr val="FFFFFF"/>
           </a:solidFill>
-          <a:ln w="9525">
+          <a:ln w="15875">
             <a:solidFill>
-              <a:srgbClr val="6B7280"/>
+              <a:srgbClr val="0EA5E9"/>
             </a:solidFill>
-            <a:prstDash val="lgDash"/>
           </a:ln>
         </p:spPr>
         <p:style>
@@ -5350,27 +5426,27 @@
             <a:r>
               <a:rPr sz="1200" b="1">
                 <a:solidFill>
+                  <a:srgbClr val="1F2937"/>
+                </a:solidFill>
+                <a:latin typeface="Calibri"/>
+              </a:rPr>
+              <a:t>Email PO Inbox  ·  LIVE</a:t>
+            </a:r>
+          </a:p>
+          <a:p>
+            <a:pPr algn="l">
+              <a:spcAft>
+                <a:spcPts val="0"/>
+              </a:spcAft>
+            </a:pPr>
+            <a:r>
+              <a:rPr sz="900" b="0">
+                <a:solidFill>
                   <a:srgbClr val="6B7280"/>
                 </a:solidFill>
                 <a:latin typeface="Calibri"/>
               </a:rPr>
-              <a:t>Roadmap: Email / WhatsApp / EDI</a:t>
-            </a:r>
-          </a:p>
-          <a:p>
-            <a:pPr algn="l">
-              <a:spcAft>
-                <a:spcPts val="0"/>
-              </a:spcAft>
-            </a:pPr>
-            <a:r>
-              <a:rPr sz="900" b="0">
-                <a:solidFill>
-                  <a:srgbClr val="6B7280"/>
-                </a:solidFill>
-                <a:latin typeface="Calibri"/>
-              </a:rPr>
-              <a:t>External channels, same gate</a:t>
+              <a:t>AI extracts emailed POs → review → order. WhatsApp / EDI next.</a:t>
             </a:r>
           </a:p>
         </p:txBody>
@@ -6156,7 +6232,7 @@
                 </a:solidFill>
                 <a:latin typeface="Calibri"/>
               </a:rPr>
-              <a:t>Nex Order   •   Process flow   •   Page 3 of 5</a:t>
+              <a:t>Nex Order   •   Process flow   •   Page 3 of 6</a:t>
             </a:r>
           </a:p>
         </p:txBody>
@@ -6459,7 +6535,7 @@
                 </a:solidFill>
                 <a:latin typeface="Calibri"/>
               </a:rPr>
-              <a:t>Pantry intelligence</a:t>
+              <a:t>AI PO Inbox</a:t>
             </a:r>
           </a:p>
           <a:p>
@@ -6475,7 +6551,7 @@
                 </a:solidFill>
                 <a:latin typeface="Calibri"/>
               </a:rPr>
-              <a:t>Per-customer reorder list, frequency-weighted suggestions, automatic out-of-stock substitutes.</a:t>
+              <a:t>Emailed &amp; PDF purchase orders read by AI, matched to customer and products, and turned into real orders — clean ones auto-approve, the rest get a quick human check.</a:t>
             </a:r>
           </a:p>
         </p:txBody>
@@ -6604,7 +6680,7 @@
                 </a:solidFill>
                 <a:latin typeface="Calibri"/>
               </a:rPr>
-              <a:t>Tier pricing &amp; promotions</a:t>
+              <a:t>Pantry intelligence</a:t>
             </a:r>
           </a:p>
           <a:p>
@@ -6620,7 +6696,7 @@
                 </a:solidFill>
                 <a:latin typeface="Calibri"/>
               </a:rPr>
-              <a:t>Gold/Silver/Bronze tiers. BOGO, bundle, and storewide promos resolved server-side at checkout.</a:t>
+              <a:t>Per-customer reorder list, frequency-weighted suggestions, automatic out-of-stock substitutes.</a:t>
             </a:r>
           </a:p>
         </p:txBody>
@@ -6749,7 +6825,7 @@
                 </a:solidFill>
                 <a:latin typeface="Calibri"/>
               </a:rPr>
-              <a:t>Routes &amp; scheduled visits</a:t>
+              <a:t>Tier pricing &amp; promotions</a:t>
             </a:r>
           </a:p>
           <a:p>
@@ -6765,7 +6841,7 @@
                 </a:solidFill>
                 <a:latin typeface="Calibri"/>
               </a:rPr>
-              <a:t>Field reps follow a planned route with stops, change requests, and on-site signature capture.</a:t>
+              <a:t>Gold/Silver/Bronze tiers. BOGO, bundle, and storewide promos resolved server-side at checkout.</a:t>
             </a:r>
           </a:p>
         </p:txBody>
@@ -6894,7 +6970,7 @@
                 </a:solidFill>
                 <a:latin typeface="Calibri"/>
               </a:rPr>
-              <a:t>Realtime cross-role visibility</a:t>
+              <a:t>Routes &amp; scheduled visits</a:t>
             </a:r>
           </a:p>
           <a:p>
@@ -6910,7 +6986,7 @@
                 </a:solidFill>
                 <a:latin typeface="Calibri"/>
               </a:rPr>
-              <a:t>Postgres LISTEN/NOTIFY + TanStack Query invalidation. Every role sees new orders without refresh.</a:t>
+              <a:t>Field reps follow a planned route with stops, change requests, and on-site signature capture.</a:t>
             </a:r>
           </a:p>
         </p:txBody>
@@ -7039,7 +7115,7 @@
                 </a:solidFill>
                 <a:latin typeface="Calibri"/>
               </a:rPr>
-              <a:t>Role-based access + audit log</a:t>
+              <a:t>Realtime, role-gated &amp; audited</a:t>
             </a:r>
           </a:p>
           <a:p>
@@ -7055,7 +7131,7 @@
                 </a:solidFill>
                 <a:latin typeface="Calibri"/>
               </a:rPr>
-              <a:t>Five roles, RLS-locked tables. Every privileged write recorded with before/after diff.</a:t>
+              <a:t>Five RLS-locked roles. Postgres realtime pushes new orders to every screen without refresh; every privileged write logged with before/after diff.</a:t>
             </a:r>
           </a:p>
         </p:txBody>
@@ -7239,7 +7315,7 @@
                 </a:solidFill>
                 <a:latin typeface="Calibri"/>
               </a:rPr>
-              <a:t>13 Edge Functions   •   5 roles   •   Postgres + RLS   •   React 19 / TypeScript / Tailwind   •   Vercel + Supabase</a:t>
+              <a:t>26 Edge Functions   •   5 roles   •   Postgres + RLS   •   React 19 / TypeScript / Tailwind   •   Vercel + Supabase</a:t>
             </a:r>
           </a:p>
         </p:txBody>
@@ -7278,7 +7354,7 @@
                 </a:solidFill>
                 <a:latin typeface="Calibri"/>
               </a:rPr>
-              <a:t>Nex Order   •   Capabilities   •   Page 4 of 5</a:t>
+              <a:t>Nex Order   •   Capabilities   •   Page 4 of 6</a:t>
             </a:r>
           </a:p>
         </p:txBody>
@@ -7413,6 +7489,1046 @@
                 </a:solidFill>
                 <a:latin typeface="Calibri"/>
               </a:rPr>
+              <a:t>AI PO INBOX</a:t>
+            </a:r>
+          </a:p>
+        </p:txBody>
+      </p:sp>
+      <p:sp>
+        <p:nvSpPr>
+          <p:cNvPr id="4" name="TextBox 3"/>
+          <p:cNvSpPr txBox="1"/>
+          <p:nvPr/>
+        </p:nvSpPr>
+        <p:spPr>
+          <a:xfrm>
+            <a:off x="548640" y="1097280"/>
+            <a:ext cx="11064240" cy="640080"/>
+          </a:xfrm>
+          <a:prstGeom prst="rect">
+            <a:avLst/>
+          </a:prstGeom>
+          <a:noFill/>
+        </p:spPr>
+        <p:txBody>
+          <a:bodyPr wrap="square" lIns="45720" rIns="45720" tIns="18288" bIns="18288" anchor="t">
+            <a:spAutoFit/>
+          </a:bodyPr>
+          <a:lstStyle/>
+          <a:p>
+            <a:pPr algn="l">
+              <a:spcAft>
+                <a:spcPts val="400"/>
+              </a:spcAft>
+            </a:pPr>
+            <a:r>
+              <a:rPr sz="3000" b="1">
+                <a:solidFill>
+                  <a:srgbClr val="1F2937"/>
+                </a:solidFill>
+                <a:latin typeface="Calibri"/>
+              </a:rPr>
+              <a:t>Your buyers already email their orders.</a:t>
+            </a:r>
+          </a:p>
+        </p:txBody>
+      </p:sp>
+      <p:sp>
+        <p:nvSpPr>
+          <p:cNvPr id="5" name="TextBox 4"/>
+          <p:cNvSpPr txBox="1"/>
+          <p:nvPr/>
+        </p:nvSpPr>
+        <p:spPr>
+          <a:xfrm>
+            <a:off x="548640" y="1783080"/>
+            <a:ext cx="11064240" cy="868680"/>
+          </a:xfrm>
+          <a:prstGeom prst="rect">
+            <a:avLst/>
+          </a:prstGeom>
+          <a:noFill/>
+        </p:spPr>
+        <p:txBody>
+          <a:bodyPr wrap="square" lIns="45720" rIns="45720" tIns="18288" bIns="18288" anchor="t">
+            <a:spAutoFit/>
+          </a:bodyPr>
+          <a:lstStyle/>
+          <a:p>
+            <a:pPr algn="l">
+              <a:spcAft>
+                <a:spcPts val="0"/>
+              </a:spcAft>
+            </a:pPr>
+            <a:r>
+              <a:rPr sz="1500" b="0">
+                <a:solidFill>
+                  <a:srgbClr val="6B7280"/>
+                </a:solidFill>
+                <a:latin typeface="Calibri"/>
+              </a:rPr>
+              <a:t>Most B2B buyers will never learn an app — they send a PO by email or PDF. PO Inbox reads it, matches it to the right customer and products, and drops a clean order into your back office. No behaviour change asked of the customer.</a:t>
+            </a:r>
+          </a:p>
+        </p:txBody>
+      </p:sp>
+      <p:sp>
+        <p:nvSpPr>
+          <p:cNvPr id="6" name="Rounded Rectangle 5"/>
+          <p:cNvSpPr/>
+          <p:nvPr/>
+        </p:nvSpPr>
+        <p:spPr>
+          <a:xfrm>
+            <a:off x="548640" y="2788920"/>
+            <a:ext cx="2567863" cy="2788920"/>
+          </a:xfrm>
+          <a:prstGeom prst="roundRect">
+            <a:avLst>
+              <a:gd name="adj" fmla="val 6000"/>
+            </a:avLst>
+          </a:prstGeom>
+          <a:solidFill>
+            <a:srgbClr val="FFFFFF"/>
+          </a:solidFill>
+          <a:ln w="15875">
+            <a:solidFill>
+              <a:srgbClr val="0EA5E9"/>
+            </a:solidFill>
+          </a:ln>
+        </p:spPr>
+        <p:style>
+          <a:lnRef idx="1">
+            <a:schemeClr val="accent1"/>
+          </a:lnRef>
+          <a:fillRef idx="3">
+            <a:schemeClr val="accent1"/>
+          </a:fillRef>
+          <a:effectRef idx="2">
+            <a:schemeClr val="accent1"/>
+          </a:effectRef>
+          <a:fontRef idx="minor">
+            <a:schemeClr val="lt1"/>
+          </a:fontRef>
+        </p:style>
+        <p:txBody>
+          <a:bodyPr rtlCol="0" anchor="ctr"/>
+          <a:lstStyle/>
+          <a:p>
+            <a:pPr algn="ctr"/>
+          </a:p>
+        </p:txBody>
+      </p:sp>
+      <p:sp>
+        <p:nvSpPr>
+          <p:cNvPr id="7" name="Rectangle 6"/>
+          <p:cNvSpPr/>
+          <p:nvPr/>
+        </p:nvSpPr>
+        <p:spPr>
+          <a:xfrm>
+            <a:off x="777240" y="3017520"/>
+            <a:ext cx="365760" cy="54864"/>
+          </a:xfrm>
+          <a:prstGeom prst="rect">
+            <a:avLst/>
+          </a:prstGeom>
+          <a:solidFill>
+            <a:srgbClr val="0EA5E9"/>
+          </a:solidFill>
+          <a:ln>
+            <a:noFill/>
+          </a:ln>
+        </p:spPr>
+        <p:style>
+          <a:lnRef idx="1">
+            <a:schemeClr val="accent1"/>
+          </a:lnRef>
+          <a:fillRef idx="3">
+            <a:schemeClr val="accent1"/>
+          </a:fillRef>
+          <a:effectRef idx="2">
+            <a:schemeClr val="accent1"/>
+          </a:effectRef>
+          <a:fontRef idx="minor">
+            <a:schemeClr val="lt1"/>
+          </a:fontRef>
+        </p:style>
+        <p:txBody>
+          <a:bodyPr rtlCol="0" anchor="ctr"/>
+          <a:lstStyle/>
+          <a:p>
+            <a:pPr algn="ctr"/>
+          </a:p>
+        </p:txBody>
+      </p:sp>
+      <p:sp>
+        <p:nvSpPr>
+          <p:cNvPr id="8" name="TextBox 7"/>
+          <p:cNvSpPr txBox="1"/>
+          <p:nvPr/>
+        </p:nvSpPr>
+        <p:spPr>
+          <a:xfrm>
+            <a:off x="777240" y="3200400"/>
+            <a:ext cx="2110663" cy="2194560"/>
+          </a:xfrm>
+          <a:prstGeom prst="rect">
+            <a:avLst/>
+          </a:prstGeom>
+          <a:noFill/>
+        </p:spPr>
+        <p:txBody>
+          <a:bodyPr wrap="square" lIns="45720" rIns="45720" tIns="18288" bIns="18288" anchor="t">
+            <a:spAutoFit/>
+          </a:bodyPr>
+          <a:lstStyle/>
+          <a:p>
+            <a:pPr algn="l">
+              <a:spcAft>
+                <a:spcPts val="600"/>
+              </a:spcAft>
+            </a:pPr>
+            <a:r>
+              <a:rPr sz="1000" b="1">
+                <a:solidFill>
+                  <a:srgbClr val="0EA5E9"/>
+                </a:solidFill>
+                <a:latin typeface="Calibri"/>
+              </a:rPr>
+              <a:t>STEP 1</a:t>
+            </a:r>
+          </a:p>
+          <a:p>
+            <a:pPr algn="l">
+              <a:spcAft>
+                <a:spcPts val="800"/>
+              </a:spcAft>
+            </a:pPr>
+            <a:r>
+              <a:rPr sz="1400" b="1">
+                <a:solidFill>
+                  <a:srgbClr val="1F2937"/>
+                </a:solidFill>
+                <a:latin typeface="Calibri"/>
+              </a:rPr>
+              <a:t>Email or PDF lands</a:t>
+            </a:r>
+          </a:p>
+          <a:p>
+            <a:pPr algn="l">
+              <a:spcAft>
+                <a:spcPts val="0"/>
+              </a:spcAft>
+            </a:pPr>
+            <a:r>
+              <a:rPr sz="1000" b="0">
+                <a:solidFill>
+                  <a:srgbClr val="6B7280"/>
+                </a:solidFill>
+                <a:latin typeface="Calibri"/>
+              </a:rPr>
+              <a:t>A connected Gmail or Outlook mailbox is polled automatically. The buyer emails the way they always have — no portal, no login.</a:t>
+            </a:r>
+          </a:p>
+        </p:txBody>
+      </p:sp>
+      <p:sp>
+        <p:nvSpPr>
+          <p:cNvPr id="9" name="Rounded Rectangle 8"/>
+          <p:cNvSpPr/>
+          <p:nvPr/>
+        </p:nvSpPr>
+        <p:spPr>
+          <a:xfrm>
+            <a:off x="3390823" y="2788920"/>
+            <a:ext cx="2567863" cy="2788920"/>
+          </a:xfrm>
+          <a:prstGeom prst="roundRect">
+            <a:avLst>
+              <a:gd name="adj" fmla="val 6000"/>
+            </a:avLst>
+          </a:prstGeom>
+          <a:solidFill>
+            <a:srgbClr val="FFFFFF"/>
+          </a:solidFill>
+          <a:ln w="15875">
+            <a:solidFill>
+              <a:srgbClr val="0EA5E9"/>
+            </a:solidFill>
+          </a:ln>
+        </p:spPr>
+        <p:style>
+          <a:lnRef idx="1">
+            <a:schemeClr val="accent1"/>
+          </a:lnRef>
+          <a:fillRef idx="3">
+            <a:schemeClr val="accent1"/>
+          </a:fillRef>
+          <a:effectRef idx="2">
+            <a:schemeClr val="accent1"/>
+          </a:effectRef>
+          <a:fontRef idx="minor">
+            <a:schemeClr val="lt1"/>
+          </a:fontRef>
+        </p:style>
+        <p:txBody>
+          <a:bodyPr rtlCol="0" anchor="ctr"/>
+          <a:lstStyle/>
+          <a:p>
+            <a:pPr algn="ctr"/>
+          </a:p>
+        </p:txBody>
+      </p:sp>
+      <p:sp>
+        <p:nvSpPr>
+          <p:cNvPr id="10" name="Rectangle 9"/>
+          <p:cNvSpPr/>
+          <p:nvPr/>
+        </p:nvSpPr>
+        <p:spPr>
+          <a:xfrm>
+            <a:off x="3619423" y="3017520"/>
+            <a:ext cx="365760" cy="54864"/>
+          </a:xfrm>
+          <a:prstGeom prst="rect">
+            <a:avLst/>
+          </a:prstGeom>
+          <a:solidFill>
+            <a:srgbClr val="0EA5E9"/>
+          </a:solidFill>
+          <a:ln>
+            <a:noFill/>
+          </a:ln>
+        </p:spPr>
+        <p:style>
+          <a:lnRef idx="1">
+            <a:schemeClr val="accent1"/>
+          </a:lnRef>
+          <a:fillRef idx="3">
+            <a:schemeClr val="accent1"/>
+          </a:fillRef>
+          <a:effectRef idx="2">
+            <a:schemeClr val="accent1"/>
+          </a:effectRef>
+          <a:fontRef idx="minor">
+            <a:schemeClr val="lt1"/>
+          </a:fontRef>
+        </p:style>
+        <p:txBody>
+          <a:bodyPr rtlCol="0" anchor="ctr"/>
+          <a:lstStyle/>
+          <a:p>
+            <a:pPr algn="ctr"/>
+          </a:p>
+        </p:txBody>
+      </p:sp>
+      <p:sp>
+        <p:nvSpPr>
+          <p:cNvPr id="11" name="TextBox 10"/>
+          <p:cNvSpPr txBox="1"/>
+          <p:nvPr/>
+        </p:nvSpPr>
+        <p:spPr>
+          <a:xfrm>
+            <a:off x="3619423" y="3200400"/>
+            <a:ext cx="2110663" cy="2194560"/>
+          </a:xfrm>
+          <a:prstGeom prst="rect">
+            <a:avLst/>
+          </a:prstGeom>
+          <a:noFill/>
+        </p:spPr>
+        <p:txBody>
+          <a:bodyPr wrap="square" lIns="45720" rIns="45720" tIns="18288" bIns="18288" anchor="t">
+            <a:spAutoFit/>
+          </a:bodyPr>
+          <a:lstStyle/>
+          <a:p>
+            <a:pPr algn="l">
+              <a:spcAft>
+                <a:spcPts val="600"/>
+              </a:spcAft>
+            </a:pPr>
+            <a:r>
+              <a:rPr sz="1000" b="1">
+                <a:solidFill>
+                  <a:srgbClr val="0EA5E9"/>
+                </a:solidFill>
+                <a:latin typeface="Calibri"/>
+              </a:rPr>
+              <a:t>STEP 2</a:t>
+            </a:r>
+          </a:p>
+          <a:p>
+            <a:pPr algn="l">
+              <a:spcAft>
+                <a:spcPts val="800"/>
+              </a:spcAft>
+            </a:pPr>
+            <a:r>
+              <a:rPr sz="1400" b="1">
+                <a:solidFill>
+                  <a:srgbClr val="1F2937"/>
+                </a:solidFill>
+                <a:latin typeface="Calibri"/>
+              </a:rPr>
+              <a:t>AI reads &amp; matches</a:t>
+            </a:r>
+          </a:p>
+          <a:p>
+            <a:pPr algn="l">
+              <a:spcAft>
+                <a:spcPts val="0"/>
+              </a:spcAft>
+            </a:pPr>
+            <a:r>
+              <a:rPr sz="1000" b="0">
+                <a:solidFill>
+                  <a:srgbClr val="6B7280"/>
+                </a:solidFill>
+                <a:latin typeface="Calibri"/>
+              </a:rPr>
+              <a:t>Parses the PDF and body, ignores signatures and clutter. Matches sender → customer and free-text items → your catalog — learning aliases on every approval.</a:t>
+            </a:r>
+          </a:p>
+        </p:txBody>
+      </p:sp>
+      <p:sp>
+        <p:nvSpPr>
+          <p:cNvPr id="12" name="Rounded Rectangle 11"/>
+          <p:cNvSpPr/>
+          <p:nvPr/>
+        </p:nvSpPr>
+        <p:spPr>
+          <a:xfrm>
+            <a:off x="6233006" y="2788920"/>
+            <a:ext cx="2567863" cy="2788920"/>
+          </a:xfrm>
+          <a:prstGeom prst="roundRect">
+            <a:avLst>
+              <a:gd name="adj" fmla="val 6000"/>
+            </a:avLst>
+          </a:prstGeom>
+          <a:solidFill>
+            <a:srgbClr val="FFFFFF"/>
+          </a:solidFill>
+          <a:ln w="15875">
+            <a:solidFill>
+              <a:srgbClr val="0EA5E9"/>
+            </a:solidFill>
+          </a:ln>
+        </p:spPr>
+        <p:style>
+          <a:lnRef idx="1">
+            <a:schemeClr val="accent1"/>
+          </a:lnRef>
+          <a:fillRef idx="3">
+            <a:schemeClr val="accent1"/>
+          </a:fillRef>
+          <a:effectRef idx="2">
+            <a:schemeClr val="accent1"/>
+          </a:effectRef>
+          <a:fontRef idx="minor">
+            <a:schemeClr val="lt1"/>
+          </a:fontRef>
+        </p:style>
+        <p:txBody>
+          <a:bodyPr rtlCol="0" anchor="ctr"/>
+          <a:lstStyle/>
+          <a:p>
+            <a:pPr algn="ctr"/>
+          </a:p>
+        </p:txBody>
+      </p:sp>
+      <p:sp>
+        <p:nvSpPr>
+          <p:cNvPr id="13" name="Rectangle 12"/>
+          <p:cNvSpPr/>
+          <p:nvPr/>
+        </p:nvSpPr>
+        <p:spPr>
+          <a:xfrm>
+            <a:off x="6461606" y="3017520"/>
+            <a:ext cx="365760" cy="54864"/>
+          </a:xfrm>
+          <a:prstGeom prst="rect">
+            <a:avLst/>
+          </a:prstGeom>
+          <a:solidFill>
+            <a:srgbClr val="0EA5E9"/>
+          </a:solidFill>
+          <a:ln>
+            <a:noFill/>
+          </a:ln>
+        </p:spPr>
+        <p:style>
+          <a:lnRef idx="1">
+            <a:schemeClr val="accent1"/>
+          </a:lnRef>
+          <a:fillRef idx="3">
+            <a:schemeClr val="accent1"/>
+          </a:fillRef>
+          <a:effectRef idx="2">
+            <a:schemeClr val="accent1"/>
+          </a:effectRef>
+          <a:fontRef idx="minor">
+            <a:schemeClr val="lt1"/>
+          </a:fontRef>
+        </p:style>
+        <p:txBody>
+          <a:bodyPr rtlCol="0" anchor="ctr"/>
+          <a:lstStyle/>
+          <a:p>
+            <a:pPr algn="ctr"/>
+          </a:p>
+        </p:txBody>
+      </p:sp>
+      <p:sp>
+        <p:nvSpPr>
+          <p:cNvPr id="14" name="TextBox 13"/>
+          <p:cNvSpPr txBox="1"/>
+          <p:nvPr/>
+        </p:nvSpPr>
+        <p:spPr>
+          <a:xfrm>
+            <a:off x="6461606" y="3200400"/>
+            <a:ext cx="2110663" cy="2194560"/>
+          </a:xfrm>
+          <a:prstGeom prst="rect">
+            <a:avLst/>
+          </a:prstGeom>
+          <a:noFill/>
+        </p:spPr>
+        <p:txBody>
+          <a:bodyPr wrap="square" lIns="45720" rIns="45720" tIns="18288" bIns="18288" anchor="t">
+            <a:spAutoFit/>
+          </a:bodyPr>
+          <a:lstStyle/>
+          <a:p>
+            <a:pPr algn="l">
+              <a:spcAft>
+                <a:spcPts val="600"/>
+              </a:spcAft>
+            </a:pPr>
+            <a:r>
+              <a:rPr sz="1000" b="1">
+                <a:solidFill>
+                  <a:srgbClr val="0EA5E9"/>
+                </a:solidFill>
+                <a:latin typeface="Calibri"/>
+              </a:rPr>
+              <a:t>STEP 3</a:t>
+            </a:r>
+          </a:p>
+          <a:p>
+            <a:pPr algn="l">
+              <a:spcAft>
+                <a:spcPts val="800"/>
+              </a:spcAft>
+            </a:pPr>
+            <a:r>
+              <a:rPr sz="1400" b="1">
+                <a:solidFill>
+                  <a:srgbClr val="1F2937"/>
+                </a:solidFill>
+                <a:latin typeface="Calibri"/>
+              </a:rPr>
+              <a:t>Auto-approve or review</a:t>
+            </a:r>
+          </a:p>
+          <a:p>
+            <a:pPr algn="l">
+              <a:spcAft>
+                <a:spcPts val="0"/>
+              </a:spcAft>
+            </a:pPr>
+            <a:r>
+              <a:rPr sz="1000" b="0">
+                <a:solidFill>
+                  <a:srgbClr val="6B7280"/>
+                </a:solidFill>
+                <a:latin typeface="Calibri"/>
+              </a:rPr>
+              <a:t>Clean, high-confidence, in-stock POs auto-approve. The rest surface with a confidence score and clear flags — sender mismatch, short stock, unresolved line — for a quick human check.</a:t>
+            </a:r>
+          </a:p>
+        </p:txBody>
+      </p:sp>
+      <p:sp>
+        <p:nvSpPr>
+          <p:cNvPr id="15" name="Rounded Rectangle 14"/>
+          <p:cNvSpPr/>
+          <p:nvPr/>
+        </p:nvSpPr>
+        <p:spPr>
+          <a:xfrm>
+            <a:off x="9075189" y="2788920"/>
+            <a:ext cx="2567863" cy="2788920"/>
+          </a:xfrm>
+          <a:prstGeom prst="roundRect">
+            <a:avLst>
+              <a:gd name="adj" fmla="val 6000"/>
+            </a:avLst>
+          </a:prstGeom>
+          <a:solidFill>
+            <a:srgbClr val="1F2937"/>
+          </a:solidFill>
+          <a:ln w="15875">
+            <a:solidFill>
+              <a:srgbClr val="0EA5E9"/>
+            </a:solidFill>
+          </a:ln>
+        </p:spPr>
+        <p:style>
+          <a:lnRef idx="1">
+            <a:schemeClr val="accent1"/>
+          </a:lnRef>
+          <a:fillRef idx="3">
+            <a:schemeClr val="accent1"/>
+          </a:fillRef>
+          <a:effectRef idx="2">
+            <a:schemeClr val="accent1"/>
+          </a:effectRef>
+          <a:fontRef idx="minor">
+            <a:schemeClr val="lt1"/>
+          </a:fontRef>
+        </p:style>
+        <p:txBody>
+          <a:bodyPr rtlCol="0" anchor="ctr"/>
+          <a:lstStyle/>
+          <a:p>
+            <a:pPr algn="ctr"/>
+          </a:p>
+        </p:txBody>
+      </p:sp>
+      <p:sp>
+        <p:nvSpPr>
+          <p:cNvPr id="16" name="Rectangle 15"/>
+          <p:cNvSpPr/>
+          <p:nvPr/>
+        </p:nvSpPr>
+        <p:spPr>
+          <a:xfrm>
+            <a:off x="9303789" y="3017520"/>
+            <a:ext cx="365760" cy="54864"/>
+          </a:xfrm>
+          <a:prstGeom prst="rect">
+            <a:avLst/>
+          </a:prstGeom>
+          <a:solidFill>
+            <a:srgbClr val="0EA5E9"/>
+          </a:solidFill>
+          <a:ln>
+            <a:noFill/>
+          </a:ln>
+        </p:spPr>
+        <p:style>
+          <a:lnRef idx="1">
+            <a:schemeClr val="accent1"/>
+          </a:lnRef>
+          <a:fillRef idx="3">
+            <a:schemeClr val="accent1"/>
+          </a:fillRef>
+          <a:effectRef idx="2">
+            <a:schemeClr val="accent1"/>
+          </a:effectRef>
+          <a:fontRef idx="minor">
+            <a:schemeClr val="lt1"/>
+          </a:fontRef>
+        </p:style>
+        <p:txBody>
+          <a:bodyPr rtlCol="0" anchor="ctr"/>
+          <a:lstStyle/>
+          <a:p>
+            <a:pPr algn="ctr"/>
+          </a:p>
+        </p:txBody>
+      </p:sp>
+      <p:sp>
+        <p:nvSpPr>
+          <p:cNvPr id="17" name="TextBox 16"/>
+          <p:cNvSpPr txBox="1"/>
+          <p:nvPr/>
+        </p:nvSpPr>
+        <p:spPr>
+          <a:xfrm>
+            <a:off x="9303789" y="3200400"/>
+            <a:ext cx="2110663" cy="2194560"/>
+          </a:xfrm>
+          <a:prstGeom prst="rect">
+            <a:avLst/>
+          </a:prstGeom>
+          <a:noFill/>
+        </p:spPr>
+        <p:txBody>
+          <a:bodyPr wrap="square" lIns="45720" rIns="45720" tIns="18288" bIns="18288" anchor="t">
+            <a:spAutoFit/>
+          </a:bodyPr>
+          <a:lstStyle/>
+          <a:p>
+            <a:pPr algn="l">
+              <a:spcAft>
+                <a:spcPts val="600"/>
+              </a:spcAft>
+            </a:pPr>
+            <a:r>
+              <a:rPr sz="1000" b="1">
+                <a:solidFill>
+                  <a:srgbClr val="0EA5E9"/>
+                </a:solidFill>
+                <a:latin typeface="Calibri"/>
+              </a:rPr>
+              <a:t>STEP 4</a:t>
+            </a:r>
+          </a:p>
+          <a:p>
+            <a:pPr algn="l">
+              <a:spcAft>
+                <a:spcPts val="800"/>
+              </a:spcAft>
+            </a:pPr>
+            <a:r>
+              <a:rPr sz="1400" b="1">
+                <a:solidFill>
+                  <a:srgbClr val="FFFFFF"/>
+                </a:solidFill>
+                <a:latin typeface="Calibri"/>
+              </a:rPr>
+              <a:t>A real order, in your books</a:t>
+            </a:r>
+          </a:p>
+          <a:p>
+            <a:pPr algn="l">
+              <a:spcAft>
+                <a:spcPts val="0"/>
+              </a:spcAft>
+            </a:pPr>
+            <a:r>
+              <a:rPr sz="1000" b="0">
+                <a:solidFill>
+                  <a:srgbClr val="E5E7EB"/>
+                </a:solidFill>
+                <a:latin typeface="Calibri"/>
+              </a:rPr>
+              <a:t>Approve and it becomes an ORD-IN order in the same orders list — same status pipeline, realtime feed, and audit log as every other channel.</a:t>
+            </a:r>
+          </a:p>
+        </p:txBody>
+      </p:sp>
+      <p:cxnSp>
+        <p:nvCxnSpPr>
+          <p:cNvPr id="18" name="Connector 17"/>
+          <p:cNvCxnSpPr/>
+          <p:nvPr/>
+        </p:nvCxnSpPr>
+        <p:spPr>
+          <a:xfrm>
+            <a:off x="3116503" y="4183380"/>
+            <a:ext cx="274320" cy="0"/>
+          </a:xfrm>
+          <a:prstGeom prst="line">
+            <a:avLst/>
+          </a:prstGeom>
+          <a:ln w="19050">
+            <a:solidFill>
+              <a:srgbClr val="0EA5E9"/>
+            </a:solidFill>
+          </a:ln>
+        </p:spPr>
+        <p:style>
+          <a:lnRef idx="2">
+            <a:schemeClr val="accent1"/>
+          </a:lnRef>
+          <a:fillRef idx="0">
+            <a:schemeClr val="accent1"/>
+          </a:fillRef>
+          <a:effectRef idx="1">
+            <a:schemeClr val="accent1"/>
+          </a:effectRef>
+          <a:fontRef idx="minor">
+            <a:schemeClr val="tx1"/>
+          </a:fontRef>
+        </p:style>
+      </p:cxnSp>
+      <p:cxnSp>
+        <p:nvCxnSpPr>
+          <p:cNvPr id="19" name="Connector 18"/>
+          <p:cNvCxnSpPr/>
+          <p:nvPr/>
+        </p:nvCxnSpPr>
+        <p:spPr>
+          <a:xfrm>
+            <a:off x="5958686" y="4183380"/>
+            <a:ext cx="274320" cy="0"/>
+          </a:xfrm>
+          <a:prstGeom prst="line">
+            <a:avLst/>
+          </a:prstGeom>
+          <a:ln w="19050">
+            <a:solidFill>
+              <a:srgbClr val="0EA5E9"/>
+            </a:solidFill>
+          </a:ln>
+        </p:spPr>
+        <p:style>
+          <a:lnRef idx="2">
+            <a:schemeClr val="accent1"/>
+          </a:lnRef>
+          <a:fillRef idx="0">
+            <a:schemeClr val="accent1"/>
+          </a:fillRef>
+          <a:effectRef idx="1">
+            <a:schemeClr val="accent1"/>
+          </a:effectRef>
+          <a:fontRef idx="minor">
+            <a:schemeClr val="tx1"/>
+          </a:fontRef>
+        </p:style>
+      </p:cxnSp>
+      <p:cxnSp>
+        <p:nvCxnSpPr>
+          <p:cNvPr id="20" name="Connector 19"/>
+          <p:cNvCxnSpPr/>
+          <p:nvPr/>
+        </p:nvCxnSpPr>
+        <p:spPr>
+          <a:xfrm>
+            <a:off x="8800869" y="4183380"/>
+            <a:ext cx="274320" cy="0"/>
+          </a:xfrm>
+          <a:prstGeom prst="line">
+            <a:avLst/>
+          </a:prstGeom>
+          <a:ln w="19050">
+            <a:solidFill>
+              <a:srgbClr val="0EA5E9"/>
+            </a:solidFill>
+          </a:ln>
+        </p:spPr>
+        <p:style>
+          <a:lnRef idx="2">
+            <a:schemeClr val="accent1"/>
+          </a:lnRef>
+          <a:fillRef idx="0">
+            <a:schemeClr val="accent1"/>
+          </a:fillRef>
+          <a:effectRef idx="1">
+            <a:schemeClr val="accent1"/>
+          </a:effectRef>
+          <a:fontRef idx="minor">
+            <a:schemeClr val="tx1"/>
+          </a:fontRef>
+        </p:style>
+      </p:cxnSp>
+      <p:sp>
+        <p:nvSpPr>
+          <p:cNvPr id="21" name="TextBox 20"/>
+          <p:cNvSpPr txBox="1"/>
+          <p:nvPr/>
+        </p:nvSpPr>
+        <p:spPr>
+          <a:xfrm>
+            <a:off x="548640" y="5897880"/>
+            <a:ext cx="11064240" cy="365760"/>
+          </a:xfrm>
+          <a:prstGeom prst="rect">
+            <a:avLst/>
+          </a:prstGeom>
+          <a:noFill/>
+        </p:spPr>
+        <p:txBody>
+          <a:bodyPr wrap="square" lIns="45720" rIns="45720" tIns="18288" bIns="18288" anchor="t">
+            <a:spAutoFit/>
+          </a:bodyPr>
+          <a:lstStyle/>
+          <a:p>
+            <a:pPr algn="ctr">
+              <a:spcAft>
+                <a:spcPts val="400"/>
+              </a:spcAft>
+            </a:pPr>
+            <a:r>
+              <a:rPr sz="1000" b="0">
+                <a:solidFill>
+                  <a:srgbClr val="6B7280"/>
+                </a:solidFill>
+                <a:latin typeface="Calibri"/>
+              </a:rPr>
+              <a:t>OAuth mailboxes (Gmail / Outlook)   •   Confidence-scored AI extraction   •   Admin / Manager-gated   •   Every approval audited</a:t>
+            </a:r>
+          </a:p>
+        </p:txBody>
+      </p:sp>
+      <p:sp>
+        <p:nvSpPr>
+          <p:cNvPr id="22" name="TextBox 21"/>
+          <p:cNvSpPr txBox="1"/>
+          <p:nvPr/>
+        </p:nvSpPr>
+        <p:spPr>
+          <a:xfrm>
+            <a:off x="548640" y="6446520"/>
+            <a:ext cx="11064240" cy="320040"/>
+          </a:xfrm>
+          <a:prstGeom prst="rect">
+            <a:avLst/>
+          </a:prstGeom>
+          <a:noFill/>
+        </p:spPr>
+        <p:txBody>
+          <a:bodyPr wrap="square" lIns="45720" rIns="45720" tIns="18288" bIns="18288" anchor="t">
+            <a:spAutoFit/>
+          </a:bodyPr>
+          <a:lstStyle/>
+          <a:p>
+            <a:pPr algn="l">
+              <a:spcAft>
+                <a:spcPts val="400"/>
+              </a:spcAft>
+            </a:pPr>
+            <a:r>
+              <a:rPr sz="900" b="0">
+                <a:solidFill>
+                  <a:srgbClr val="6B7280"/>
+                </a:solidFill>
+                <a:latin typeface="Calibri"/>
+              </a:rPr>
+              <a:t>Nex Order   •   PO Inbox   •   Page 5 of 6</a:t>
+            </a:r>
+          </a:p>
+        </p:txBody>
+      </p:sp>
+      <p:cxnSp>
+        <p:nvCxnSpPr>
+          <p:cNvPr id="23" name="Connector 22"/>
+          <p:cNvCxnSpPr/>
+          <p:nvPr/>
+        </p:nvCxnSpPr>
+        <p:spPr>
+          <a:xfrm>
+            <a:off x="548640" y="6400800"/>
+            <a:ext cx="11064240" cy="0"/>
+          </a:xfrm>
+          <a:prstGeom prst="line">
+            <a:avLst/>
+          </a:prstGeom>
+          <a:ln w="6350">
+            <a:solidFill>
+              <a:srgbClr val="E5E7EB"/>
+            </a:solidFill>
+          </a:ln>
+        </p:spPr>
+        <p:style>
+          <a:lnRef idx="2">
+            <a:schemeClr val="accent1"/>
+          </a:lnRef>
+          <a:fillRef idx="0">
+            <a:schemeClr val="accent1"/>
+          </a:fillRef>
+          <a:effectRef idx="1">
+            <a:schemeClr val="accent1"/>
+          </a:effectRef>
+          <a:fontRef idx="minor">
+            <a:schemeClr val="tx1"/>
+          </a:fontRef>
+        </p:style>
+      </p:cxnSp>
+    </p:spTree>
+  </p:cSld>
+  <p:clrMapOvr>
+    <a:masterClrMapping/>
+  </p:clrMapOvr>
+</p:sld>
+</file>
+
+<file path=ppt/slides/slide6.xml><?xml version="1.0" encoding="utf-8"?>
+<p:sld xmlns:a="http://schemas.openxmlformats.org/drawingml/2006/main" xmlns:p="http://schemas.openxmlformats.org/presentationml/2006/main" xmlns:r="http://schemas.openxmlformats.org/officeDocument/2006/relationships">
+  <p:cSld>
+    <p:spTree>
+      <p:nvGrpSpPr>
+        <p:cNvPr id="1" name=""/>
+        <p:cNvGrpSpPr/>
+        <p:nvPr/>
+      </p:nvGrpSpPr>
+      <p:grpSpPr/>
+      <p:sp>
+        <p:nvSpPr>
+          <p:cNvPr id="2" name="Rectangle 1"/>
+          <p:cNvSpPr/>
+          <p:nvPr/>
+        </p:nvSpPr>
+        <p:spPr>
+          <a:xfrm>
+            <a:off x="548640" y="548640"/>
+            <a:ext cx="548640" cy="73152"/>
+          </a:xfrm>
+          <a:prstGeom prst="rect">
+            <a:avLst/>
+          </a:prstGeom>
+          <a:solidFill>
+            <a:srgbClr val="0EA5E9"/>
+          </a:solidFill>
+          <a:ln>
+            <a:noFill/>
+          </a:ln>
+        </p:spPr>
+        <p:style>
+          <a:lnRef idx="1">
+            <a:schemeClr val="accent1"/>
+          </a:lnRef>
+          <a:fillRef idx="3">
+            <a:schemeClr val="accent1"/>
+          </a:fillRef>
+          <a:effectRef idx="2">
+            <a:schemeClr val="accent1"/>
+          </a:effectRef>
+          <a:fontRef idx="minor">
+            <a:schemeClr val="lt1"/>
+          </a:fontRef>
+        </p:style>
+        <p:txBody>
+          <a:bodyPr rtlCol="0" anchor="ctr"/>
+          <a:lstStyle/>
+          <a:p>
+            <a:pPr algn="ctr"/>
+          </a:p>
+        </p:txBody>
+      </p:sp>
+      <p:sp>
+        <p:nvSpPr>
+          <p:cNvPr id="3" name="TextBox 2"/>
+          <p:cNvSpPr txBox="1"/>
+          <p:nvPr/>
+        </p:nvSpPr>
+        <p:spPr>
+          <a:xfrm>
+            <a:off x="548640" y="713232"/>
+            <a:ext cx="5486400" cy="320040"/>
+          </a:xfrm>
+          <a:prstGeom prst="rect">
+            <a:avLst/>
+          </a:prstGeom>
+          <a:noFill/>
+        </p:spPr>
+        <p:txBody>
+          <a:bodyPr wrap="square" lIns="45720" rIns="45720" tIns="18288" bIns="18288" anchor="t">
+            <a:spAutoFit/>
+          </a:bodyPr>
+          <a:lstStyle/>
+          <a:p>
+            <a:pPr algn="l">
+              <a:spcAft>
+                <a:spcPts val="400"/>
+              </a:spcAft>
+            </a:pPr>
+            <a:r>
+              <a:rPr sz="1100" b="1">
+                <a:solidFill>
+                  <a:srgbClr val="0EA5E9"/>
+                </a:solidFill>
+                <a:latin typeface="Calibri"/>
+              </a:rPr>
               <a:t>LIVE DEMO</a:t>
             </a:r>
           </a:p>
@@ -8123,7 +9239,7 @@
                 </a:solidFill>
                 <a:latin typeface="Calibri"/>
               </a:rPr>
-              <a:t>Nex Order   •   Live demo   •   Page 5 of 5</a:t>
+              <a:t>Nex Order   •   Live demo   •   Page 6 of 6</a:t>
             </a:r>
           </a:p>
         </p:txBody>

</xml_diff>